<commit_message>
Revise week 6 workshop: reorder exercises, add notebook kernel steps and channel check, move to Python 3.14
</commit_message>
<xml_diff>
--- a/workshops/week06/conda_slides.pptx
+++ b/workshops/week06/conda_slides.pptx
@@ -15,8 +15,8 @@
     <p:sldId id="264" r:id="rId9"/>
     <p:sldId id="265" r:id="rId10"/>
     <p:sldId id="266" r:id="rId11"/>
+    <p:sldId id="268" r:id="rId13"/>
     <p:sldId id="267" r:id="rId12"/>
-    <p:sldId id="268" r:id="rId13"/>
     <p:sldId id="269" r:id="rId14"/>
     <p:sldId id="270" r:id="rId15"/>
     <p:sldId id="271" r:id="rId16"/>
@@ -787,7 +787,7 @@
                 <a:ea typeface="Calibri" pitchFamily="34" charset="-122"/>
                 <a:cs typeface="Calibri" pitchFamily="34" charset="-120"/>
               </a:rPr>
-              <a:t>11</a:t>
+              <a:t>10</a:t>
             </a:r>
             <a:endParaRPr lang="en-US" sz="1100" dirty="0"/>
           </a:p>
@@ -1430,7 +1430,7 @@
               <a:buNone/>
             </a:pPr>
             <a:r>
-              <a:rPr lang="en-US" sz="1350" b="1" dirty="0">
+              <a:rPr lang="en-US" sz="1600" b="1" i="1" dirty="0">
                 <a:solidFill>
                   <a:srgbClr val="1E2761"/>
                 </a:solidFill>
@@ -1441,7 +1441,7 @@
               <a:t>You just destroyed an environment and recreated it from a text file</a:t>
             </a:r>
             <a:r>
-              <a:rPr lang="en-US" sz="1350" dirty="0">
+              <a:rPr lang="en-US" sz="1600" i="1" dirty="0">
                 <a:solidFill>
                   <a:srgbClr val="1E2761"/>
                 </a:solidFill>
@@ -1451,7 +1451,7 @@
               </a:rPr>
               <a:t>. That file is the whole point of today.</a:t>
             </a:r>
-            <a:endParaRPr lang="en-US" sz="1350" dirty="0"/>
+            <a:endParaRPr lang="en-US" sz="1600" i="1" dirty="0"/>
           </a:p>
         </p:txBody>
       </p:sp>
@@ -1679,7 +1679,7 @@
                 <a:ea typeface="Cambria" pitchFamily="34" charset="-122"/>
                 <a:cs typeface="Cambria" pitchFamily="34" charset="-120"/>
               </a:rPr>
-              <a:t>Exercise 3 — Recreate Someone Else's Project</a:t>
+              <a:t>Exercise 4 — Recreate Someone Else's Project</a:t>
             </a:r>
             <a:endParaRPr lang="en-US" sz="3200" dirty="0"/>
           </a:p>
@@ -1994,7 +1994,7 @@
                 <a:ea typeface="Calibri" pitchFamily="34" charset="-122"/>
                 <a:cs typeface="Calibri" pitchFamily="34" charset="-120"/>
               </a:rPr>
-              <a:t>Build the environment from that file, and select it as your interpreter in VS Code</a:t>
+              <a:t>Build the environment from that file</a:t>
             </a:r>
             <a:endParaRPr lang="en-US" sz="1550" dirty="0"/>
           </a:p>
@@ -2099,7 +2099,7 @@
                 <a:ea typeface="Calibri" pitchFamily="34" charset="-122"/>
                 <a:cs typeface="Calibri" pitchFamily="34" charset="-120"/>
               </a:rPr>
-              <a:t>Run the app, and open the URL that appears in the terminal</a:t>
+              <a:t>Open the notebook, select temp-conversion-app as its kernel, and click Run All — then open the link below the last cell</a:t>
             </a:r>
             <a:endParaRPr lang="en-US" sz="1550" dirty="0"/>
           </a:p>
@@ -2164,7 +2164,7 @@
               <a:buNone/>
             </a:pPr>
             <a:r>
-              <a:rPr lang="en-US" sz="1350" b="1" dirty="0">
+              <a:rPr lang="en-US" sz="1600" b="1" i="1" dirty="0">
                 <a:solidFill>
                   <a:srgbClr val="1E2761"/>
                 </a:solidFill>
@@ -2175,7 +2175,7 @@
               <a:t>You are about to run a project built with a package you have never used</a:t>
             </a:r>
             <a:r>
-              <a:rPr lang="en-US" sz="1350" dirty="0">
+              <a:rPr lang="en-US" sz="1600" i="1" dirty="0">
                 <a:solidFill>
                   <a:srgbClr val="1E2761"/>
                 </a:solidFill>
@@ -2185,7 +2185,7 @@
               </a:rPr>
               <a:t>, without installing anything by hand. That is what an environment file buys you.</a:t>
             </a:r>
-            <a:endParaRPr lang="en-US" sz="1350" dirty="0"/>
+            <a:endParaRPr lang="en-US" sz="1600" i="1" dirty="0"/>
           </a:p>
         </p:txBody>
       </p:sp>
@@ -2255,7 +2255,7 @@
                 <a:ea typeface="Calibri" pitchFamily="34" charset="-122"/>
                 <a:cs typeface="Calibri" pitchFamily="34" charset="-120"/>
               </a:rPr>
-              <a:t>13</a:t>
+              <a:t>11</a:t>
             </a:r>
             <a:endParaRPr lang="en-US" sz="1100" dirty="0"/>
           </a:p>
@@ -2413,7 +2413,7 @@
                 <a:ea typeface="Cambria" pitchFamily="34" charset="-122"/>
                 <a:cs typeface="Cambria" pitchFamily="34" charset="-120"/>
               </a:rPr>
-              <a:t>Exercise 4 — Your Part 2 Environment</a:t>
+              <a:t>Exercise 3 — Your Part 2 Environment</a:t>
             </a:r>
             <a:endParaRPr lang="en-US" sz="3200" dirty="0"/>
           </a:p>
@@ -2728,7 +2728,7 @@
                 <a:ea typeface="Calibri" pitchFamily="34" charset="-122"/>
                 <a:cs typeface="Calibri" pitchFamily="34" charset="-120"/>
               </a:rPr>
-              <a:t>Activate it, and confirm that pandas is installed</a:t>
+              <a:t>Activate it, and confirm that pandas is installed — but sympy is not</a:t>
             </a:r>
             <a:endParaRPr lang="en-US" sz="1550" dirty="0"/>
           </a:p>
@@ -2833,7 +2833,7 @@
                 <a:ea typeface="Calibri" pitchFamily="34" charset="-122"/>
                 <a:cs typeface="Calibri" pitchFamily="34" charset="-120"/>
               </a:rPr>
-              <a:t>Keep this one — you will use it for the rest of the course</a:t>
+              <a:t>Run the import check in a notebook with TECH2 as its kernel — then keep this environment for the rest of the course</a:t>
             </a:r>
             <a:endParaRPr lang="en-US" sz="1550" dirty="0"/>
           </a:p>
@@ -2898,7 +2898,7 @@
               <a:buNone/>
             </a:pPr>
             <a:r>
-              <a:rPr lang="en-US" sz="1350" b="1" dirty="0">
+              <a:rPr lang="en-US" sz="1600" b="1" i="1" dirty="0">
                 <a:solidFill>
                   <a:srgbClr val="1E2761"/>
                 </a:solidFill>
@@ -2909,7 +2909,7 @@
               <a:t>conda env create --file</a:t>
             </a:r>
             <a:r>
-              <a:rPr lang="en-US" sz="1350" dirty="0">
+              <a:rPr lang="en-US" sz="1600" i="1" dirty="0">
                 <a:solidFill>
                   <a:srgbClr val="1E2761"/>
                 </a:solidFill>
@@ -2919,7 +2919,7 @@
               </a:rPr>
               <a:t> accepts a web address just as happily as a file on your own computer.</a:t>
             </a:r>
-            <a:endParaRPr lang="en-US" sz="1350" dirty="0"/>
+            <a:endParaRPr lang="en-US" sz="1600" i="1" dirty="0"/>
           </a:p>
         </p:txBody>
       </p:sp>
@@ -2989,7 +2989,7 @@
                 <a:ea typeface="Calibri" pitchFamily="34" charset="-122"/>
                 <a:cs typeface="Calibri" pitchFamily="34" charset="-120"/>
               </a:rPr>
-              <a:t>14</a:t>
+              <a:t>13</a:t>
             </a:r>
             <a:endParaRPr lang="en-US" sz="1100" dirty="0"/>
           </a:p>
@@ -3397,7 +3397,7 @@
               <a:buNone/>
             </a:pPr>
             <a:r>
-              <a:rPr lang="en-US" sz="1350" b="1" dirty="0">
+              <a:rPr lang="en-US" sz="1600" b="1" i="1" dirty="0">
                 <a:solidFill>
                   <a:srgbClr val="1E2761"/>
                 </a:solidFill>
@@ -3408,7 +3408,7 @@
               <a:t>Careful</a:t>
             </a:r>
             <a:r>
-              <a:rPr lang="en-US" sz="1350" dirty="0">
+              <a:rPr lang="en-US" sz="1600" i="1" dirty="0">
                 <a:solidFill>
                   <a:srgbClr val="1E2761"/>
                 </a:solidFill>
@@ -3418,7 +3418,7 @@
               </a:rPr>
               <a:t>: --from-history does not record pip installs. If you used pip, add those packages to environment.yml yourself.</a:t>
             </a:r>
-            <a:endParaRPr lang="en-US" sz="1350" dirty="0"/>
+            <a:endParaRPr lang="en-US" sz="1600" i="1" dirty="0"/>
           </a:p>
         </p:txBody>
       </p:sp>
@@ -3488,7 +3488,7 @@
                 <a:ea typeface="Calibri" pitchFamily="34" charset="-122"/>
                 <a:cs typeface="Calibri" pitchFamily="34" charset="-120"/>
               </a:rPr>
-              <a:t>15</a:t>
+              <a:t>14</a:t>
             </a:r>
             <a:endParaRPr lang="en-US" sz="1100" dirty="0"/>
           </a:p>
@@ -3981,7 +3981,7 @@
                 <a:ea typeface="Calibri" pitchFamily="34" charset="-122"/>
                 <a:cs typeface="Calibri" pitchFamily="34" charset="-120"/>
               </a:rPr>
-              <a:t>temp-conversion-app — someone else's project, running on your machine</a:t>
+              <a:t>Your Part 2 environment — ready for pandas and matplotlib</a:t>
             </a:r>
             <a:endParaRPr lang="en-US" sz="1600" dirty="0"/>
           </a:p>
@@ -4002,7 +4002,7 @@
                 <a:ea typeface="Calibri" pitchFamily="34" charset="-122"/>
                 <a:cs typeface="Calibri" pitchFamily="34" charset="-120"/>
               </a:rPr>
-              <a:t>Your Part 2 environment — ready for pandas and matplotlib</a:t>
+              <a:t>temp-conversion-app — someone else's project, running on your machine</a:t>
             </a:r>
             <a:endParaRPr lang="en-US" sz="1600" dirty="0"/>
           </a:p>
@@ -4531,7 +4531,7 @@
               <a:buNone/>
             </a:pPr>
             <a:r>
-              <a:rPr lang="en-US" sz="1350" b="1" dirty="0">
+              <a:rPr lang="en-US" sz="1600" b="1" i="1" dirty="0">
                 <a:solidFill>
                   <a:srgbClr val="1E2761"/>
                 </a:solidFill>
@@ -4542,7 +4542,7 @@
               <a:t>Today's goal</a:t>
             </a:r>
             <a:r>
-              <a:rPr lang="en-US" sz="1350" dirty="0">
+              <a:rPr lang="en-US" sz="1600" i="1" dirty="0">
                 <a:solidFill>
                   <a:srgbClr val="1E2761"/>
                 </a:solidFill>
@@ -4552,7 +4552,7 @@
               </a:rPr>
               <a:t>: leave base alone, and give every project an environment of its own.</a:t>
             </a:r>
-            <a:endParaRPr lang="en-US" sz="1350" dirty="0"/>
+            <a:endParaRPr lang="en-US" sz="1600" i="1" dirty="0"/>
           </a:p>
         </p:txBody>
       </p:sp>
@@ -4951,28 +4951,28 @@
               <a:buNone/>
             </a:pPr>
             <a:r>
-              <a:rPr lang="en-US" sz="1350" b="1" dirty="0">
-                <a:solidFill>
-                  <a:srgbClr val="1E2761"/>
-                </a:solidFill>
-                <a:latin typeface="Calibri" pitchFamily="34" charset="0"/>
-                <a:ea typeface="Calibri" pitchFamily="34" charset="-122"/>
-                <a:cs typeface="Calibri" pitchFamily="34" charset="-120"/>
-              </a:rPr>
-              <a:t>You already have everything you need</a:t>
-            </a:r>
-            <a:r>
-              <a:rPr lang="en-US" sz="1350" dirty="0">
-                <a:solidFill>
-                  <a:srgbClr val="1E2761"/>
-                </a:solidFill>
-                <a:latin typeface="Calibri" pitchFamily="34" charset="0"/>
-                <a:ea typeface="Calibri" pitchFamily="34" charset="-122"/>
-                <a:cs typeface="Calibri" pitchFamily="34" charset="-120"/>
-              </a:rPr>
-              <a:t> — conda came with Miniforge when you installed it before the course.</a:t>
-            </a:r>
-            <a:endParaRPr lang="en-US" sz="1350" dirty="0"/>
+              <a:rPr lang="en-US" sz="1600" b="1" i="1" dirty="0">
+                <a:solidFill>
+                  <a:srgbClr val="1E2761"/>
+                </a:solidFill>
+                <a:latin typeface="Calibri" pitchFamily="34" charset="0"/>
+                <a:ea typeface="Calibri" pitchFamily="34" charset="-122"/>
+                <a:cs typeface="Calibri" pitchFamily="34" charset="-120"/>
+              </a:rPr>
+              <a:t>Where packages live:</a:t>
+            </a:r>
+            <a:r>
+              <a:rPr lang="en-US" sz="1600" i="1" dirty="0">
+                <a:solidFill>
+                  <a:srgbClr val="1E2761"/>
+                </a:solidFill>
+                <a:latin typeface="Calibri" pitchFamily="34" charset="0"/>
+                <a:ea typeface="Calibri" pitchFamily="34" charset="-122"/>
+                <a:cs typeface="Calibri" pitchFamily="34" charset="-120"/>
+              </a:rPr>
+              <a:t> conda-forge.org — every conda install and conda create downloads its packages from there.</a:t>
+            </a:r>
+            <a:endParaRPr lang="en-US" sz="1600" i="1" dirty="0"/>
           </a:p>
         </p:txBody>
       </p:sp>
@@ -5371,7 +5371,7 @@
               <a:buNone/>
             </a:pPr>
             <a:r>
-              <a:rPr lang="en-US" sz="1350" b="1" dirty="0">
+              <a:rPr lang="en-US" sz="1600" b="1" i="1" dirty="0">
                 <a:solidFill>
                   <a:srgbClr val="1E2761"/>
                 </a:solidFill>
@@ -5382,7 +5382,7 @@
               <a:t>The prompt tells you where you are</a:t>
             </a:r>
             <a:r>
-              <a:rPr lang="en-US" sz="1350" dirty="0">
+              <a:rPr lang="en-US" sz="1600" i="1" dirty="0">
                 <a:solidFill>
                   <a:srgbClr val="1E2761"/>
                 </a:solidFill>
@@ -5392,7 +5392,7 @@
               </a:rPr>
               <a:t>: (base) means you are in the base environment, (my_env) means you are in yours.</a:t>
             </a:r>
-            <a:endParaRPr lang="en-US" sz="1350" dirty="0"/>
+            <a:endParaRPr lang="en-US" sz="1600" i="1" dirty="0"/>
           </a:p>
         </p:txBody>
       </p:sp>
@@ -5867,7 +5867,7 @@
               <a:buNone/>
             </a:pPr>
             <a:r>
-              <a:rPr lang="en-US" sz="1350" b="1" dirty="0">
+              <a:rPr lang="en-US" sz="1600" b="1" i="1" dirty="0">
                 <a:solidFill>
                   <a:srgbClr val="1E2761"/>
                 </a:solidFill>
@@ -5878,7 +5878,7 @@
               <a:t>The whole idea</a:t>
             </a:r>
             <a:r>
-              <a:rPr lang="en-US" sz="1350" dirty="0">
+              <a:rPr lang="en-US" sz="1600" i="1" dirty="0">
                 <a:solidFill>
                   <a:srgbClr val="1E2761"/>
                 </a:solidFill>
@@ -5888,7 +5888,7 @@
               </a:rPr>
               <a:t>: one project's mess stays inside that project.</a:t>
             </a:r>
-            <a:endParaRPr lang="en-US" sz="1350" dirty="0"/>
+            <a:endParaRPr lang="en-US" sz="1600" i="1" dirty="0"/>
           </a:p>
         </p:txBody>
       </p:sp>
@@ -6431,7 +6431,112 @@
                 <a:ea typeface="Calibri" pitchFamily="34" charset="-122"/>
                 <a:cs typeface="Calibri" pitchFamily="34" charset="-120"/>
               </a:rPr>
-              <a:t>conda list — shows what is installed in base right now. Have a look at what is in there.</a:t>
+              <a:t>conda list — shows what is installed in base right now. You should see numpy, matplotlib and sympy from the lecture.</a:t>
+            </a:r>
+            <a:endParaRPr lang="en-US" sz="1550" dirty="0"/>
+          </a:p>
+        </p:txBody>
+      </p:sp>
+      <p:sp>
+        <p:nvSpPr>
+          <p:cNvPr id="28" name="Badge"/>
+          <p:cNvSpPr/>
+          <p:nvPr/>
+        </p:nvSpPr>
+        <p:spPr>
+          <a:xfrm>
+            <a:off x="822960" y="4480560"/>
+            <a:ext cx="384048" cy="384048"/>
+          </a:xfrm>
+          <a:prstGeom prst="ellipse">
+            <a:avLst/>
+          </a:prstGeom>
+          <a:solidFill>
+            <a:srgbClr val="F96167"/>
+          </a:solidFill>
+          <a:ln/>
+        </p:spPr>
+        <p:txBody>
+          <a:bodyPr/>
+          <a:lstStyle/>
+          <a:p>
+            <a:endParaRPr/>
+          </a:p>
+        </p:txBody>
+      </p:sp>
+      <p:sp>
+        <p:nvSpPr>
+          <p:cNvPr id="29" name="BadgeNum"/>
+          <p:cNvSpPr/>
+          <p:nvPr/>
+        </p:nvSpPr>
+        <p:spPr>
+          <a:xfrm>
+            <a:off x="822960" y="4480560"/>
+            <a:ext cx="384048" cy="384048"/>
+          </a:xfrm>
+          <a:prstGeom prst="rect">
+            <a:avLst/>
+          </a:prstGeom>
+          <a:noFill/>
+          <a:ln/>
+        </p:spPr>
+        <p:txBody>
+          <a:bodyPr wrap="square" lIns="0" tIns="0" rIns="0" bIns="0" rtlCol="0" anchor="ctr"/>
+          <a:lstStyle/>
+          <a:p>
+            <a:pPr marL="0" indent="0" algn="ctr">
+              <a:buNone/>
+            </a:pPr>
+            <a:r>
+              <a:rPr lang="en-US" sz="1400" dirty="0">
+                <a:solidFill>
+                  <a:srgbClr val="FFFFFF"/>
+                </a:solidFill>
+                <a:latin typeface="Calibri" pitchFamily="34" charset="0"/>
+                <a:ea typeface="Calibri" pitchFamily="34" charset="-122"/>
+                <a:cs typeface="Calibri" pitchFamily="34" charset="-120"/>
+              </a:rPr>
+              <a:t>4</a:t>
+            </a:r>
+            <a:endParaRPr lang="en-US" sz="1400" dirty="0"/>
+          </a:p>
+        </p:txBody>
+      </p:sp>
+      <p:sp>
+        <p:nvSpPr>
+          <p:cNvPr id="30" name="StepText"/>
+          <p:cNvSpPr/>
+          <p:nvPr/>
+        </p:nvSpPr>
+        <p:spPr>
+          <a:xfrm>
+            <a:off x="1371600" y="4453128"/>
+            <a:ext cx="9966960" cy="566928"/>
+          </a:xfrm>
+          <a:prstGeom prst="rect">
+            <a:avLst/>
+          </a:prstGeom>
+          <a:noFill/>
+          <a:ln/>
+        </p:spPr>
+        <p:txBody>
+          <a:bodyPr wrap="square" lIns="0" tIns="0" rIns="0" bIns="0" rtlCol="0" anchor="ctr"/>
+          <a:lstStyle/>
+          <a:p>
+            <a:pPr marL="0" indent="0" algn="l">
+              <a:buNone/>
+            </a:pPr>
+            <a:r>
+              <a:rPr lang="en-US" sz="1550" dirty="0">
+                <a:solidFill>
+                  <a:srgbClr val="1E2761"/>
+                </a:solidFill>
+                <a:latin typeface="Calibri" pitchFamily="34" charset="0"/>
+                <a:ea typeface="Calibri" pitchFamily="34" charset="-122"/>
+                <a:cs typeface="Calibri" pitchFamily="34" charset="-120"/>
+              </a:rPr>
+              <a:t>conda config --show channels — shows where conda gets packages from. It should say conda-forge and nothing else.</a:t>
             </a:r>
             <a:endParaRPr lang="en-US" sz="1550" dirty="0"/>
           </a:p>
@@ -6496,28 +6601,28 @@
               <a:buNone/>
             </a:pPr>
             <a:r>
-              <a:rPr lang="en-US" sz="1350" b="1" dirty="0">
-                <a:solidFill>
-                  <a:srgbClr val="1E2761"/>
-                </a:solidFill>
-                <a:latin typeface="Calibri" pitchFamily="34" charset="0"/>
-                <a:ea typeface="Calibri" pitchFamily="34" charset="-122"/>
-                <a:cs typeface="Calibri" pitchFamily="34" charset="-120"/>
-              </a:rPr>
-              <a:t>Two documents today</a:t>
-            </a:r>
-            <a:r>
-              <a:rPr lang="en-US" sz="1350" dirty="0">
-                <a:solidFill>
-                  <a:srgbClr val="1E2761"/>
-                </a:solidFill>
-                <a:latin typeface="Calibri" pitchFamily="34" charset="0"/>
-                <a:ea typeface="Calibri" pitchFamily="34" charset="-122"/>
-                <a:cs typeface="Calibri" pitchFamily="34" charset="-120"/>
-              </a:rPr>
-              <a:t>: the conda guide (a general reference for the whole course), and exercises.md (today's exact commands — copy and paste from there).</a:t>
-            </a:r>
-            <a:endParaRPr lang="en-US" sz="1350" dirty="0"/>
+              <a:rPr lang="en-US" sz="1600" b="1" i="1" dirty="0">
+                <a:solidFill>
+                  <a:srgbClr val="1E2761"/>
+                </a:solidFill>
+                <a:latin typeface="Calibri" pitchFamily="34" charset="0"/>
+                <a:ea typeface="Calibri" pitchFamily="34" charset="-122"/>
+                <a:cs typeface="Calibri" pitchFamily="34" charset="-120"/>
+              </a:rPr>
+              <a:t>All commands are in exercises.md</a:t>
+            </a:r>
+            <a:r>
+              <a:rPr lang="en-US" sz="1600" i="1" dirty="0">
+                <a:solidFill>
+                  <a:srgbClr val="1E2761"/>
+                </a:solidFill>
+                <a:latin typeface="Calibri" pitchFamily="34" charset="0"/>
+                <a:ea typeface="Calibri" pitchFamily="34" charset="-122"/>
+                <a:cs typeface="Calibri" pitchFamily="34" charset="-120"/>
+              </a:rPr>
+              <a:t> — copy and paste them from there rather than typing them by hand.</a:t>
+            </a:r>
+            <a:endParaRPr lang="en-US" sz="1600" i="1" dirty="0"/>
           </a:p>
         </p:txBody>
       </p:sp>
@@ -6788,7 +6893,7 @@
                 <a:ea typeface="Calibri" pitchFamily="34" charset="-122"/>
                 <a:cs typeface="Calibri" pitchFamily="34" charset="-120"/>
               </a:rPr>
-              <a:t>conda create --name my_env python=3.13 pandas</a:t>
+              <a:t>conda create --name my_env python=3.14 pandas</a:t>
             </a:r>
             <a:endParaRPr lang="en-US" sz="1600" dirty="0"/>
           </a:p>
@@ -6841,7 +6946,7 @@
                 <a:ea typeface="Calibri" pitchFamily="34" charset="-122"/>
                 <a:cs typeface="Calibri" pitchFamily="34" charset="-120"/>
               </a:rPr>
-              <a:t>python=3.13</a:t>
+              <a:t>python=3.14</a:t>
             </a:r>
             <a:r>
               <a:rPr lang="en-US" sz="1600" dirty="0">
@@ -7020,7 +7125,7 @@
           <a:lstStyle/>
           <a:p>
             <a:r>
-              <a:rPr lang="en-US" sz="1350" b="1" dirty="0" err="1">
+              <a:rPr lang="en-US" sz="1600" b="1" i="1" dirty="0" err="1">
                 <a:solidFill>
                   <a:srgbClr val="1E2761"/>
                 </a:solidFill>
@@ -7031,7 +7136,7 @@
               <a:t>ModuleNotFoundError</a:t>
             </a:r>
             <a:r>
-              <a:rPr lang="en-US" sz="1350" dirty="0">
+              <a:rPr lang="en-US" sz="1600" i="1" dirty="0">
                 <a:solidFill>
                   <a:srgbClr val="1E2761"/>
                 </a:solidFill>
@@ -7041,7 +7146,7 @@
               </a:rPr>
               <a:t> for a package you know you installed? You are almost certainly in the wrong environment.</a:t>
             </a:r>
-            <a:endParaRPr lang="en-US" sz="1350" dirty="0"/>
+            <a:endParaRPr lang="en-US" sz="1600" i="1" dirty="0"/>
           </a:p>
         </p:txBody>
       </p:sp>
@@ -7099,20 +7204,24 @@
           <a:bodyPr wrap="square" lIns="0" tIns="0" rIns="0" bIns="0" rtlCol="0" anchor="t"/>
           <a:lstStyle/>
           <a:p>
+            <a:pPr algn="ctr"/>
+            <a:r>
+              <a:rPr lang="en-US" sz="1100" dirty="0">
+                <a:solidFill>
+                  <a:srgbClr val="5B6472"/>
+                </a:solidFill>
+                <a:latin typeface="Calibri" pitchFamily="34" charset="0"/>
+                <a:ea typeface="Calibri" pitchFamily="34" charset="-122"/>
+                <a:cs typeface="Calibri" pitchFamily="34" charset="-120"/>
+              </a:rPr>
+              <a:t>8</a:t>
+            </a:r>
+            <a:endParaRPr lang="en-US" sz="1100" dirty="0"/>
+          </a:p>
+          <a:p>
             <a:pPr marL="0" indent="0" algn="ctr">
               <a:buNone/>
             </a:pPr>
-            <a:r>
-              <a:rPr lang="en-US" sz="1100" dirty="0">
-                <a:solidFill>
-                  <a:srgbClr val="5B6472"/>
-                </a:solidFill>
-                <a:latin typeface="Calibri" pitchFamily="34" charset="0"/>
-                <a:ea typeface="Calibri" pitchFamily="34" charset="-122"/>
-                <a:cs typeface="Calibri" pitchFamily="34" charset="-120"/>
-              </a:rPr>
-              <a:t>9</a:t>
-            </a:r>
             <a:endParaRPr lang="en-US" sz="1100" dirty="0"/>
           </a:p>
         </p:txBody>
@@ -7374,7 +7483,7 @@
                 <a:ea typeface="Calibri" pitchFamily="34" charset="-122"/>
                 <a:cs typeface="Calibri" pitchFamily="34" charset="-120"/>
               </a:rPr>
-              <a:t>Part A: create tech2-test with Python 3.13 and pandas, then activate it</a:t>
+              <a:t>Part A: create tech2-test with Python 3.14 and pandas, then activate it</a:t>
             </a:r>
             <a:endParaRPr lang="en-US" sz="1550" dirty="0"/>
           </a:p>
@@ -7754,7 +7863,7 @@
               <a:buNone/>
             </a:pPr>
             <a:r>
-              <a:rPr lang="en-US" sz="1350" b="1" dirty="0">
+              <a:rPr lang="en-US" sz="1600" b="1" i="1" dirty="0">
                 <a:solidFill>
                   <a:srgbClr val="1E2761"/>
                 </a:solidFill>
@@ -7765,7 +7874,7 @@
               <a:t>Expect the last step to fail</a:t>
             </a:r>
             <a:r>
-              <a:rPr lang="en-US" sz="1350" dirty="0">
+              <a:rPr lang="en-US" sz="1600" i="1" dirty="0">
                 <a:solidFill>
                   <a:srgbClr val="1E2761"/>
                 </a:solidFill>
@@ -7775,7 +7884,7 @@
               </a:rPr>
               <a:t> — that is the point of the exercise. Commands are in exercises.md.</a:t>
             </a:r>
-            <a:endParaRPr lang="en-US" sz="1350" dirty="0"/>
+            <a:endParaRPr lang="en-US" sz="1600" i="1" dirty="0"/>
           </a:p>
         </p:txBody>
       </p:sp>
@@ -7845,7 +7954,7 @@
                 <a:ea typeface="Calibri" pitchFamily="34" charset="-122"/>
                 <a:cs typeface="Calibri" pitchFamily="34" charset="-120"/>
               </a:rPr>
-              <a:t>10</a:t>
+              <a:t>9</a:t>
             </a:r>
             <a:endParaRPr lang="en-US" sz="1100" dirty="0"/>
           </a:p>
@@ -8174,7 +8283,7 @@
               <a:buNone/>
             </a:pPr>
             <a:r>
-              <a:rPr lang="en-US" sz="1350" b="1" dirty="0">
+              <a:rPr lang="en-US" sz="1600" b="1" i="1" dirty="0">
                 <a:solidFill>
                   <a:srgbClr val="1E2761"/>
                 </a:solidFill>
@@ -8185,7 +8294,7 @@
               <a:t>Use --from-history</a:t>
             </a:r>
             <a:r>
-              <a:rPr lang="en-US" sz="1350" dirty="0">
+              <a:rPr lang="en-US" sz="1600" i="1" dirty="0">
                 <a:solidFill>
                   <a:srgbClr val="1E2761"/>
                 </a:solidFill>
@@ -8195,7 +8304,7 @@
               </a:rPr>
               <a:t>. A plain export also lists every automatically-installed dependency, pinned to versions that may only exist on your computer.</a:t>
             </a:r>
-            <a:endParaRPr lang="en-US" sz="1350" dirty="0"/>
+            <a:endParaRPr lang="en-US" sz="1600" i="1" dirty="0"/>
           </a:p>
         </p:txBody>
       </p:sp>

</xml_diff>